<commit_message>
updated rmd files for unit 4
</commit_message>
<xml_diff>
--- a/Unit 4 Tidyverse/Exploratory Data Analysis NASA API.pptx
+++ b/Unit 4 Tidyverse/Exploratory Data Analysis NASA API.pptx
@@ -9,6 +9,7 @@
     <p:sldId id="257" r:id="rId3"/>
     <p:sldId id="258" r:id="rId4"/>
     <p:sldId id="259" r:id="rId5"/>
+    <p:sldId id="260" r:id="rId6"/>
   </p:sldIdLst>
   <p:sldSz cx="12192000" cy="6858000"/>
   <p:notesSz cx="6858000" cy="9144000"/>
@@ -107,6 +108,11 @@
       </a:defRPr>
     </a:lvl9pPr>
   </p:defaultTextStyle>
+  <p:extLst>
+    <p:ext uri="{EFAFB233-063F-42B5-8137-9DF3F51BA10A}">
+      <p15:sldGuideLst xmlns:p15="http://schemas.microsoft.com/office/powerpoint/2012/main"/>
+    </p:ext>
+  </p:extLst>
 </p:presentation>
 </file>
 
@@ -8503,8 +8509,23 @@
             </a:pPr>
             <a:r>
               <a:rPr lang="en-US" dirty="0"/>
-              <a:t>#Full code here: </a:t>
-            </a:r>
+              <a:t>#Full code here:</a:t>
+            </a:r>
+          </a:p>
+          <a:p>
+            <a:pPr marL="0" indent="0">
+              <a:spcBef>
+                <a:spcPts val="0"/>
+              </a:spcBef>
+              <a:buNone/>
+            </a:pPr>
+            <a:r>
+              <a:rPr lang="en-US" dirty="0">
+                <a:hlinkClick r:id="rId2"/>
+              </a:rPr>
+              <a:t>https://github.com/Iwestlauer/doing_data_science/blob/main/Unit%204%20Tidyverse/Web_Scraping.Rmd </a:t>
+            </a:r>
+            <a:endParaRPr lang="en-US" dirty="0"/>
           </a:p>
           <a:p>
             <a:pPr marL="0" indent="0">
@@ -10129,6 +10150,228 @@
     <p:extLst>
       <p:ext uri="{BB962C8B-B14F-4D97-AF65-F5344CB8AC3E}">
         <p14:creationId xmlns:p14="http://schemas.microsoft.com/office/powerpoint/2010/main" val="3083098348"/>
+      </p:ext>
+    </p:extLst>
+  </p:cSld>
+  <p:clrMapOvr>
+    <a:masterClrMapping/>
+  </p:clrMapOvr>
+</p:sld>
+</file>
+
+<file path=ppt/slides/slide5.xml><?xml version="1.0" encoding="utf-8"?>
+<p:sld xmlns:a="http://schemas.openxmlformats.org/drawingml/2006/main" xmlns:r="http://schemas.openxmlformats.org/officeDocument/2006/relationships" xmlns:p="http://schemas.openxmlformats.org/presentationml/2006/main">
+  <p:cSld>
+    <p:spTree>
+      <p:nvGrpSpPr>
+        <p:cNvPr id="1" name=""/>
+        <p:cNvGrpSpPr/>
+        <p:nvPr/>
+      </p:nvGrpSpPr>
+      <p:grpSpPr>
+        <a:xfrm>
+          <a:off x="0" y="0"/>
+          <a:ext cx="0" cy="0"/>
+          <a:chOff x="0" y="0"/>
+          <a:chExt cx="0" cy="0"/>
+        </a:xfrm>
+      </p:grpSpPr>
+      <p:sp>
+        <p:nvSpPr>
+          <p:cNvPr id="2" name="Title 1">
+            <a:extLst>
+              <a:ext uri="{FF2B5EF4-FFF2-40B4-BE49-F238E27FC236}">
+                <a16:creationId xmlns:a16="http://schemas.microsoft.com/office/drawing/2014/main" id="{0EB3CBFF-E51B-6EEB-C001-E46D9E98202D}"/>
+              </a:ext>
+            </a:extLst>
+          </p:cNvPr>
+          <p:cNvSpPr>
+            <a:spLocks noGrp="1"/>
+          </p:cNvSpPr>
+          <p:nvPr>
+            <p:ph type="title"/>
+          </p:nvPr>
+        </p:nvSpPr>
+        <p:spPr/>
+        <p:txBody>
+          <a:bodyPr/>
+          <a:lstStyle/>
+          <a:p>
+            <a:r>
+              <a:rPr lang="en-US" dirty="0"/>
+              <a:t>Obstacles</a:t>
+            </a:r>
+          </a:p>
+        </p:txBody>
+      </p:sp>
+      <p:sp>
+        <p:nvSpPr>
+          <p:cNvPr id="3" name="Content Placeholder 2">
+            <a:extLst>
+              <a:ext uri="{FF2B5EF4-FFF2-40B4-BE49-F238E27FC236}">
+                <a16:creationId xmlns:a16="http://schemas.microsoft.com/office/drawing/2014/main" id="{BCDAEC3E-6290-E14E-E3AD-B0DBB9D5F190}"/>
+              </a:ext>
+            </a:extLst>
+          </p:cNvPr>
+          <p:cNvSpPr>
+            <a:spLocks noGrp="1"/>
+          </p:cNvSpPr>
+          <p:nvPr>
+            <p:ph idx="1"/>
+          </p:nvPr>
+        </p:nvSpPr>
+        <p:spPr>
+          <a:xfrm>
+            <a:off x="838200" y="1825625"/>
+            <a:ext cx="5703277" cy="4351338"/>
+          </a:xfrm>
+        </p:spPr>
+        <p:txBody>
+          <a:bodyPr>
+            <a:normAutofit fontScale="85000" lnSpcReduction="20000"/>
+          </a:bodyPr>
+          <a:lstStyle/>
+          <a:p>
+            <a:r>
+              <a:rPr lang="en-US" dirty="0"/>
+              <a:t>Had to use </a:t>
+            </a:r>
+            <a:r>
+              <a:rPr lang="en-US" dirty="0" err="1"/>
+              <a:t>unlist</a:t>
+            </a:r>
+            <a:r>
+              <a:rPr lang="en-US" dirty="0"/>
+              <a:t>()</a:t>
+            </a:r>
+          </a:p>
+          <a:p>
+            <a:r>
+              <a:rPr lang="en-US" dirty="0"/>
+              <a:t>The </a:t>
+            </a:r>
+            <a:r>
+              <a:rPr lang="en-US" dirty="0" err="1"/>
+              <a:t>httr</a:t>
+            </a:r>
+            <a:r>
+              <a:rPr lang="en-US" dirty="0"/>
+              <a:t> </a:t>
+            </a:r>
+            <a:r>
+              <a:rPr lang="en-US" dirty="0" err="1"/>
+              <a:t>url</a:t>
+            </a:r>
+            <a:r>
+              <a:rPr lang="en-US" dirty="0"/>
+              <a:t> had fields=field1,field2 which </a:t>
+            </a:r>
+            <a:r>
+              <a:rPr lang="en-US" i="1" dirty="0"/>
+              <a:t>cannot have any spaces between the field names</a:t>
+            </a:r>
+            <a:r>
+              <a:rPr lang="en-US" dirty="0"/>
+              <a:t>, or you will get a 400 error</a:t>
+            </a:r>
+          </a:p>
+          <a:p>
+            <a:r>
+              <a:rPr lang="en-US" dirty="0"/>
+              <a:t>If you don’t put a limit on your request and it’s just too much, you will get a 400 error</a:t>
+            </a:r>
+          </a:p>
+          <a:p>
+            <a:r>
+              <a:rPr lang="en-US" dirty="0"/>
+              <a:t>I couldn’t get usable data from </a:t>
+            </a:r>
+            <a:r>
+              <a:rPr lang="en-US" dirty="0" err="1"/>
+              <a:t>sbdb</a:t>
+            </a:r>
+            <a:r>
+              <a:rPr lang="en-US" dirty="0"/>
+              <a:t> </a:t>
+            </a:r>
+            <a:r>
+              <a:rPr lang="en-US" dirty="0" err="1"/>
+              <a:t>api</a:t>
+            </a:r>
+            <a:r>
+              <a:rPr lang="en-US" dirty="0"/>
+              <a:t>, had to use </a:t>
+            </a:r>
+            <a:r>
+              <a:rPr lang="en-US" dirty="0" err="1"/>
+              <a:t>sbdb</a:t>
+            </a:r>
+            <a:r>
+              <a:rPr lang="en-US" dirty="0"/>
+              <a:t> query </a:t>
+            </a:r>
+            <a:r>
+              <a:rPr lang="en-US" dirty="0" err="1"/>
+              <a:t>api</a:t>
+            </a:r>
+            <a:endParaRPr lang="en-US" dirty="0"/>
+          </a:p>
+          <a:p>
+            <a:r>
+              <a:rPr lang="en-US" dirty="0"/>
+              <a:t>The date field from the </a:t>
+            </a:r>
+            <a:r>
+              <a:rPr lang="en-US" dirty="0" err="1"/>
+              <a:t>json</a:t>
+            </a:r>
+            <a:r>
+              <a:rPr lang="en-US" dirty="0"/>
+              <a:t> was a string, but I had to convert it to a date</a:t>
+            </a:r>
+          </a:p>
+          <a:p>
+            <a:r>
+              <a:rPr lang="en-US" dirty="0"/>
+              <a:t>Tried a boxplot but didn’t know how to interpret it</a:t>
+            </a:r>
+          </a:p>
+        </p:txBody>
+      </p:sp>
+      <p:pic>
+        <p:nvPicPr>
+          <p:cNvPr id="6" name="Picture 5">
+            <a:extLst>
+              <a:ext uri="{FF2B5EF4-FFF2-40B4-BE49-F238E27FC236}">
+                <a16:creationId xmlns:a16="http://schemas.microsoft.com/office/drawing/2014/main" id="{07A40DD5-2B46-19E5-0614-EB29CAE897E4}"/>
+              </a:ext>
+            </a:extLst>
+          </p:cNvPr>
+          <p:cNvPicPr>
+            <a:picLocks noChangeAspect="1"/>
+          </p:cNvPicPr>
+          <p:nvPr/>
+        </p:nvPicPr>
+        <p:blipFill>
+          <a:blip r:embed="rId2"/>
+          <a:stretch>
+            <a:fillRect/>
+          </a:stretch>
+        </p:blipFill>
+        <p:spPr>
+          <a:xfrm>
+            <a:off x="6541477" y="1359877"/>
+            <a:ext cx="5474316" cy="4981209"/>
+          </a:xfrm>
+          <a:prstGeom prst="rect">
+            <a:avLst/>
+          </a:prstGeom>
+        </p:spPr>
+      </p:pic>
+    </p:spTree>
+    <p:extLst>
+      <p:ext uri="{BB962C8B-B14F-4D97-AF65-F5344CB8AC3E}">
+        <p14:creationId xmlns:p14="http://schemas.microsoft.com/office/powerpoint/2010/main" val="111804241"/>
       </p:ext>
     </p:extLst>
   </p:cSld>

</xml_diff>